<commit_message>
map: Sync all map latest contents
Signed-off-by: Chen Gang <chengang_19780320@qq.com>
</commit_message>
<xml_diff>
--- a/toolchains/runtime-xxx/runtime-analyzing/运行时分析.pptx
+++ b/toolchains/runtime-xxx/runtime-analyzing/运行时分析.pptx
@@ -9180,7 +9180,7 @@
                   <a:schemeClr val="accent6"/>
                 </a:solidFill>
               </a:rPr>
-              <a:t>动态：运行时监控是主要数据来源，运行时调试是主要处理方法。</a:t>
+              <a:t>动态：实践（运行时监控是主要数据来源，运行时调试是主要处理方法）；理论（整理总结）。</a:t>
             </a:r>
             <a:endParaRPr lang="zh-CN" altLang="en-US">
               <a:solidFill>
@@ -9454,7 +9454,16 @@
                   <a:schemeClr val="accent6"/>
                 </a:solidFill>
               </a:rPr>
-              <a:t>动态：运行时监控是主要数据来源，运行时调试是主要处理方法。</a:t>
+              <a:t>动态：</a:t>
+            </a:r>
+            <a:r>
+              <a:rPr lang="zh-CN" altLang="en-US">
+                <a:solidFill>
+                  <a:schemeClr val="accent6"/>
+                </a:solidFill>
+                <a:sym typeface="+mn-ea"/>
+              </a:rPr>
+              <a:t>实践（运行时监控是主要数据来源，运行时调试是主要处理方法）；理论（整理总结）。</a:t>
             </a:r>
             <a:endParaRPr lang="zh-CN" altLang="en-US">
               <a:solidFill>
@@ -9869,7 +9878,16 @@
                   <a:schemeClr val="accent6"/>
                 </a:solidFill>
               </a:rPr>
-              <a:t>动态：运行时监控是主要数据来源，运行时调试是主要处理方法。</a:t>
+              <a:t>动态：</a:t>
+            </a:r>
+            <a:r>
+              <a:rPr lang="zh-CN" altLang="en-US">
+                <a:solidFill>
+                  <a:schemeClr val="accent6"/>
+                </a:solidFill>
+                <a:sym typeface="+mn-ea"/>
+              </a:rPr>
+              <a:t>实践（运行时监控是主要数据来源，运行时调试是主要处理方法）；理论（整理总结）。</a:t>
             </a:r>
             <a:endParaRPr lang="zh-CN" altLang="en-US">
               <a:solidFill>

</xml_diff>